<commit_message>
HVC9 Update in PPT document
HVC9 Update in PPT document
</commit_message>
<xml_diff>
--- a/docs/evidence/HVB16A_Group4_CapstoneProject.pptx
+++ b/docs/evidence/HVB16A_Group4_CapstoneProject.pptx
@@ -312,7 +312,7 @@
           <a:p>
             <a:fld id="{5BCAD085-E8A6-8845-BD4E-CB4CCA059FC4}" type="datetimeFigureOut">
               <a:rPr lang="en-US" smtClean="0"/>
-              <a:t>10/30/2026</a:t>
+              <a:t>10/31/2026</a:t>
             </a:fld>
             <a:endParaRPr lang="en-US"/>
           </a:p>
@@ -480,7 +480,7 @@
           <a:p>
             <a:fld id="{5BCAD085-E8A6-8845-BD4E-CB4CCA059FC4}" type="datetimeFigureOut">
               <a:rPr lang="en-US" smtClean="0"/>
-              <a:t>10/30/2026</a:t>
+              <a:t>10/31/2026</a:t>
             </a:fld>
             <a:endParaRPr lang="en-US"/>
           </a:p>
@@ -658,7 +658,7 @@
           <a:p>
             <a:fld id="{5BCAD085-E8A6-8845-BD4E-CB4CCA059FC4}" type="datetimeFigureOut">
               <a:rPr lang="en-US" smtClean="0"/>
-              <a:t>10/30/2026</a:t>
+              <a:t>10/31/2026</a:t>
             </a:fld>
             <a:endParaRPr lang="en-US"/>
           </a:p>
@@ -826,7 +826,7 @@
           <a:p>
             <a:fld id="{5BCAD085-E8A6-8845-BD4E-CB4CCA059FC4}" type="datetimeFigureOut">
               <a:rPr lang="en-US" smtClean="0"/>
-              <a:t>10/30/2026</a:t>
+              <a:t>10/31/2026</a:t>
             </a:fld>
             <a:endParaRPr lang="en-US"/>
           </a:p>
@@ -1071,7 +1071,7 @@
           <a:p>
             <a:fld id="{5BCAD085-E8A6-8845-BD4E-CB4CCA059FC4}" type="datetimeFigureOut">
               <a:rPr lang="en-US" smtClean="0"/>
-              <a:t>10/30/2026</a:t>
+              <a:t>10/31/2026</a:t>
             </a:fld>
             <a:endParaRPr lang="en-US"/>
           </a:p>
@@ -1356,7 +1356,7 @@
           <a:p>
             <a:fld id="{5BCAD085-E8A6-8845-BD4E-CB4CCA059FC4}" type="datetimeFigureOut">
               <a:rPr lang="en-US" smtClean="0"/>
-              <a:t>10/30/2026</a:t>
+              <a:t>10/31/2026</a:t>
             </a:fld>
             <a:endParaRPr lang="en-US"/>
           </a:p>
@@ -1775,7 +1775,7 @@
           <a:p>
             <a:fld id="{5BCAD085-E8A6-8845-BD4E-CB4CCA059FC4}" type="datetimeFigureOut">
               <a:rPr lang="en-US" smtClean="0"/>
-              <a:t>10/30/2026</a:t>
+              <a:t>10/31/2026</a:t>
             </a:fld>
             <a:endParaRPr lang="en-US"/>
           </a:p>
@@ -1892,7 +1892,7 @@
           <a:p>
             <a:fld id="{5BCAD085-E8A6-8845-BD4E-CB4CCA059FC4}" type="datetimeFigureOut">
               <a:rPr lang="en-US" smtClean="0"/>
-              <a:t>10/30/2026</a:t>
+              <a:t>10/31/2026</a:t>
             </a:fld>
             <a:endParaRPr lang="en-US"/>
           </a:p>
@@ -1987,7 +1987,7 @@
           <a:p>
             <a:fld id="{5BCAD085-E8A6-8845-BD4E-CB4CCA059FC4}" type="datetimeFigureOut">
               <a:rPr lang="en-US" smtClean="0"/>
-              <a:t>10/30/2026</a:t>
+              <a:t>10/31/2026</a:t>
             </a:fld>
             <a:endParaRPr lang="en-US"/>
           </a:p>
@@ -2262,7 +2262,7 @@
           <a:p>
             <a:fld id="{5BCAD085-E8A6-8845-BD4E-CB4CCA059FC4}" type="datetimeFigureOut">
               <a:rPr lang="en-US" smtClean="0"/>
-              <a:t>10/30/2026</a:t>
+              <a:t>10/31/2026</a:t>
             </a:fld>
             <a:endParaRPr lang="en-US"/>
           </a:p>
@@ -2514,7 +2514,7 @@
           <a:p>
             <a:fld id="{5BCAD085-E8A6-8845-BD4E-CB4CCA059FC4}" type="datetimeFigureOut">
               <a:rPr lang="en-US" smtClean="0"/>
-              <a:t>10/30/2026</a:t>
+              <a:t>10/31/2026</a:t>
             </a:fld>
             <a:endParaRPr lang="en-US"/>
           </a:p>
@@ -2725,7 +2725,7 @@
           <a:p>
             <a:fld id="{5BCAD085-E8A6-8845-BD4E-CB4CCA059FC4}" type="datetimeFigureOut">
               <a:rPr lang="en-US" smtClean="0"/>
-              <a:t>10/30/2026</a:t>
+              <a:t>10/31/2026</a:t>
             </a:fld>
             <a:endParaRPr lang="en-US"/>
           </a:p>
@@ -3132,16 +3132,52 @@
           </a:prstGeom>
         </p:spPr>
       </p:pic>
-      <p:sp>
-        <p:nvSpPr>
-          <p:cNvPr id="3" name="Rounded Rectangle 2"/>
+      <p:pic>
+        <p:nvPicPr>
+          <p:cNvPr id="8" name="Picture 7">
+            <a:extLst>
+              <a:ext uri="{FF2B5EF4-FFF2-40B4-BE49-F238E27FC236}">
+                <a16:creationId xmlns:a16="http://schemas.microsoft.com/office/drawing/2014/main" id="{280A4E37-8659-58ED-D2DD-B7B15ED7EE4A}"/>
+              </a:ext>
+            </a:extLst>
+          </p:cNvPr>
+          <p:cNvPicPr>
+            <a:picLocks noChangeAspect="1"/>
+          </p:cNvPicPr>
+          <p:nvPr/>
+        </p:nvPicPr>
+        <p:blipFill>
+          <a:blip r:embed="rId3"/>
+          <a:stretch>
+            <a:fillRect/>
+          </a:stretch>
+        </p:blipFill>
+        <p:spPr>
+          <a:xfrm>
+            <a:off x="0" y="0"/>
+            <a:ext cx="12192000" cy="6858000"/>
+          </a:xfrm>
+          <a:prstGeom prst="rect">
+            <a:avLst/>
+          </a:prstGeom>
+        </p:spPr>
+      </p:pic>
+      <p:sp>
+        <p:nvSpPr>
+          <p:cNvPr id="9" name="Rounded Rectangle 2">
+            <a:extLst>
+              <a:ext uri="{FF2B5EF4-FFF2-40B4-BE49-F238E27FC236}">
+                <a16:creationId xmlns:a16="http://schemas.microsoft.com/office/drawing/2014/main" id="{5B628EE1-C89D-3F40-F7D7-AA3D22FA5854}"/>
+              </a:ext>
+            </a:extLst>
+          </p:cNvPr>
           <p:cNvSpPr/>
           <p:nvPr/>
         </p:nvSpPr>
         <p:spPr>
           <a:xfrm>
-            <a:off x="4756249" y="2398514"/>
-            <a:ext cx="2679352" cy="304800"/>
+            <a:off x="4314825" y="1868834"/>
+            <a:ext cx="3562350" cy="295275"/>
           </a:xfrm>
           <a:prstGeom prst="roundRect">
             <a:avLst>
@@ -3149,11 +3185,11 @@
             </a:avLst>
           </a:prstGeom>
           <a:solidFill>
-            <a:srgbClr val="192046"/>
+            <a:srgbClr val="2B1C5D"/>
           </a:solidFill>
           <a:ln w="9525">
             <a:solidFill>
-              <a:srgbClr val="1D2B59"/>
+              <a:srgbClr val="7C3AED"/>
             </a:solidFill>
           </a:ln>
           <a:effectLst/>
@@ -3174,7 +3210,101 @@
         </p:style>
         <p:txBody>
           <a:bodyPr rtlCol="0" anchor="ctr"/>
-          <a:lstStyle/>
+          <a:lstStyle>
+            <a:defPPr>
+              <a:defRPr lang="en-US"/>
+            </a:defPPr>
+            <a:lvl1pPr marL="0" algn="l" defTabSz="457200" rtl="0" eaLnBrk="1" latinLnBrk="0" hangingPunct="1">
+              <a:defRPr sz="1800" kern="1200">
+                <a:solidFill>
+                  <a:schemeClr val="lt1"/>
+                </a:solidFill>
+                <a:latin typeface="+mn-lt"/>
+                <a:ea typeface="+mn-ea"/>
+                <a:cs typeface="+mn-cs"/>
+              </a:defRPr>
+            </a:lvl1pPr>
+            <a:lvl2pPr marL="457200" algn="l" defTabSz="457200" rtl="0" eaLnBrk="1" latinLnBrk="0" hangingPunct="1">
+              <a:defRPr sz="1800" kern="1200">
+                <a:solidFill>
+                  <a:schemeClr val="lt1"/>
+                </a:solidFill>
+                <a:latin typeface="+mn-lt"/>
+                <a:ea typeface="+mn-ea"/>
+                <a:cs typeface="+mn-cs"/>
+              </a:defRPr>
+            </a:lvl2pPr>
+            <a:lvl3pPr marL="914400" algn="l" defTabSz="457200" rtl="0" eaLnBrk="1" latinLnBrk="0" hangingPunct="1">
+              <a:defRPr sz="1800" kern="1200">
+                <a:solidFill>
+                  <a:schemeClr val="lt1"/>
+                </a:solidFill>
+                <a:latin typeface="+mn-lt"/>
+                <a:ea typeface="+mn-ea"/>
+                <a:cs typeface="+mn-cs"/>
+              </a:defRPr>
+            </a:lvl3pPr>
+            <a:lvl4pPr marL="1371600" algn="l" defTabSz="457200" rtl="0" eaLnBrk="1" latinLnBrk="0" hangingPunct="1">
+              <a:defRPr sz="1800" kern="1200">
+                <a:solidFill>
+                  <a:schemeClr val="lt1"/>
+                </a:solidFill>
+                <a:latin typeface="+mn-lt"/>
+                <a:ea typeface="+mn-ea"/>
+                <a:cs typeface="+mn-cs"/>
+              </a:defRPr>
+            </a:lvl4pPr>
+            <a:lvl5pPr marL="1828800" algn="l" defTabSz="457200" rtl="0" eaLnBrk="1" latinLnBrk="0" hangingPunct="1">
+              <a:defRPr sz="1800" kern="1200">
+                <a:solidFill>
+                  <a:schemeClr val="lt1"/>
+                </a:solidFill>
+                <a:latin typeface="+mn-lt"/>
+                <a:ea typeface="+mn-ea"/>
+                <a:cs typeface="+mn-cs"/>
+              </a:defRPr>
+            </a:lvl5pPr>
+            <a:lvl6pPr marL="2286000" algn="l" defTabSz="457200" rtl="0" eaLnBrk="1" latinLnBrk="0" hangingPunct="1">
+              <a:defRPr sz="1800" kern="1200">
+                <a:solidFill>
+                  <a:schemeClr val="lt1"/>
+                </a:solidFill>
+                <a:latin typeface="+mn-lt"/>
+                <a:ea typeface="+mn-ea"/>
+                <a:cs typeface="+mn-cs"/>
+              </a:defRPr>
+            </a:lvl6pPr>
+            <a:lvl7pPr marL="2743200" algn="l" defTabSz="457200" rtl="0" eaLnBrk="1" latinLnBrk="0" hangingPunct="1">
+              <a:defRPr sz="1800" kern="1200">
+                <a:solidFill>
+                  <a:schemeClr val="lt1"/>
+                </a:solidFill>
+                <a:latin typeface="+mn-lt"/>
+                <a:ea typeface="+mn-ea"/>
+                <a:cs typeface="+mn-cs"/>
+              </a:defRPr>
+            </a:lvl7pPr>
+            <a:lvl8pPr marL="3200400" algn="l" defTabSz="457200" rtl="0" eaLnBrk="1" latinLnBrk="0" hangingPunct="1">
+              <a:defRPr sz="1800" kern="1200">
+                <a:solidFill>
+                  <a:schemeClr val="lt1"/>
+                </a:solidFill>
+                <a:latin typeface="+mn-lt"/>
+                <a:ea typeface="+mn-ea"/>
+                <a:cs typeface="+mn-cs"/>
+              </a:defRPr>
+            </a:lvl8pPr>
+            <a:lvl9pPr marL="3657600" algn="l" defTabSz="457200" rtl="0" eaLnBrk="1" latinLnBrk="0" hangingPunct="1">
+              <a:defRPr sz="1800" kern="1200">
+                <a:solidFill>
+                  <a:schemeClr val="lt1"/>
+                </a:solidFill>
+                <a:latin typeface="+mn-lt"/>
+                <a:ea typeface="+mn-ea"/>
+                <a:cs typeface="+mn-cs"/>
+              </a:defRPr>
+            </a:lvl9pPr>
+          </a:lstStyle>
           <a:p>
             <a:pPr algn="ctr"/>
             <a:endParaRPr/>
@@ -3183,14 +3313,289 @@
       </p:sp>
       <p:sp>
         <p:nvSpPr>
-          <p:cNvPr id="4" name="TextBox 3"/>
+          <p:cNvPr id="10" name="Rounded Rectangle 3">
+            <a:extLst>
+              <a:ext uri="{FF2B5EF4-FFF2-40B4-BE49-F238E27FC236}">
+                <a16:creationId xmlns:a16="http://schemas.microsoft.com/office/drawing/2014/main" id="{D0A20642-C4A0-E986-A250-519B998C1BCA}"/>
+              </a:ext>
+            </a:extLst>
+          </p:cNvPr>
+          <p:cNvSpPr/>
+          <p:nvPr/>
+        </p:nvSpPr>
+        <p:spPr>
+          <a:xfrm>
+            <a:off x="2524125" y="4131915"/>
+            <a:ext cx="7143750" cy="857250"/>
+          </a:xfrm>
+          <a:prstGeom prst="roundRect">
+            <a:avLst>
+              <a:gd name="adj" fmla="val 13333"/>
+            </a:avLst>
+          </a:prstGeom>
+          <a:solidFill>
+            <a:srgbClr val="232143"/>
+          </a:solidFill>
+          <a:ln w="9525">
+            <a:solidFill>
+              <a:srgbClr val="2E2C4D"/>
+            </a:solidFill>
+          </a:ln>
+          <a:effectLst/>
+        </p:spPr>
+        <p:style>
+          <a:lnRef idx="1">
+            <a:schemeClr val="accent1"/>
+          </a:lnRef>
+          <a:fillRef idx="3">
+            <a:schemeClr val="accent1"/>
+          </a:fillRef>
+          <a:effectRef idx="2">
+            <a:schemeClr val="accent1"/>
+          </a:effectRef>
+          <a:fontRef idx="minor">
+            <a:schemeClr val="lt1"/>
+          </a:fontRef>
+        </p:style>
+        <p:txBody>
+          <a:bodyPr rtlCol="0" anchor="ctr"/>
+          <a:lstStyle>
+            <a:defPPr>
+              <a:defRPr lang="en-US"/>
+            </a:defPPr>
+            <a:lvl1pPr marL="0" algn="l" defTabSz="457200" rtl="0" eaLnBrk="1" latinLnBrk="0" hangingPunct="1">
+              <a:defRPr sz="1800" kern="1200">
+                <a:solidFill>
+                  <a:schemeClr val="lt1"/>
+                </a:solidFill>
+                <a:latin typeface="+mn-lt"/>
+                <a:ea typeface="+mn-ea"/>
+                <a:cs typeface="+mn-cs"/>
+              </a:defRPr>
+            </a:lvl1pPr>
+            <a:lvl2pPr marL="457200" algn="l" defTabSz="457200" rtl="0" eaLnBrk="1" latinLnBrk="0" hangingPunct="1">
+              <a:defRPr sz="1800" kern="1200">
+                <a:solidFill>
+                  <a:schemeClr val="lt1"/>
+                </a:solidFill>
+                <a:latin typeface="+mn-lt"/>
+                <a:ea typeface="+mn-ea"/>
+                <a:cs typeface="+mn-cs"/>
+              </a:defRPr>
+            </a:lvl2pPr>
+            <a:lvl3pPr marL="914400" algn="l" defTabSz="457200" rtl="0" eaLnBrk="1" latinLnBrk="0" hangingPunct="1">
+              <a:defRPr sz="1800" kern="1200">
+                <a:solidFill>
+                  <a:schemeClr val="lt1"/>
+                </a:solidFill>
+                <a:latin typeface="+mn-lt"/>
+                <a:ea typeface="+mn-ea"/>
+                <a:cs typeface="+mn-cs"/>
+              </a:defRPr>
+            </a:lvl3pPr>
+            <a:lvl4pPr marL="1371600" algn="l" defTabSz="457200" rtl="0" eaLnBrk="1" latinLnBrk="0" hangingPunct="1">
+              <a:defRPr sz="1800" kern="1200">
+                <a:solidFill>
+                  <a:schemeClr val="lt1"/>
+                </a:solidFill>
+                <a:latin typeface="+mn-lt"/>
+                <a:ea typeface="+mn-ea"/>
+                <a:cs typeface="+mn-cs"/>
+              </a:defRPr>
+            </a:lvl4pPr>
+            <a:lvl5pPr marL="1828800" algn="l" defTabSz="457200" rtl="0" eaLnBrk="1" latinLnBrk="0" hangingPunct="1">
+              <a:defRPr sz="1800" kern="1200">
+                <a:solidFill>
+                  <a:schemeClr val="lt1"/>
+                </a:solidFill>
+                <a:latin typeface="+mn-lt"/>
+                <a:ea typeface="+mn-ea"/>
+                <a:cs typeface="+mn-cs"/>
+              </a:defRPr>
+            </a:lvl5pPr>
+            <a:lvl6pPr marL="2286000" algn="l" defTabSz="457200" rtl="0" eaLnBrk="1" latinLnBrk="0" hangingPunct="1">
+              <a:defRPr sz="1800" kern="1200">
+                <a:solidFill>
+                  <a:schemeClr val="lt1"/>
+                </a:solidFill>
+                <a:latin typeface="+mn-lt"/>
+                <a:ea typeface="+mn-ea"/>
+                <a:cs typeface="+mn-cs"/>
+              </a:defRPr>
+            </a:lvl6pPr>
+            <a:lvl7pPr marL="2743200" algn="l" defTabSz="457200" rtl="0" eaLnBrk="1" latinLnBrk="0" hangingPunct="1">
+              <a:defRPr sz="1800" kern="1200">
+                <a:solidFill>
+                  <a:schemeClr val="lt1"/>
+                </a:solidFill>
+                <a:latin typeface="+mn-lt"/>
+                <a:ea typeface="+mn-ea"/>
+                <a:cs typeface="+mn-cs"/>
+              </a:defRPr>
+            </a:lvl7pPr>
+            <a:lvl8pPr marL="3200400" algn="l" defTabSz="457200" rtl="0" eaLnBrk="1" latinLnBrk="0" hangingPunct="1">
+              <a:defRPr sz="1800" kern="1200">
+                <a:solidFill>
+                  <a:schemeClr val="lt1"/>
+                </a:solidFill>
+                <a:latin typeface="+mn-lt"/>
+                <a:ea typeface="+mn-ea"/>
+                <a:cs typeface="+mn-cs"/>
+              </a:defRPr>
+            </a:lvl8pPr>
+            <a:lvl9pPr marL="3657600" algn="l" defTabSz="457200" rtl="0" eaLnBrk="1" latinLnBrk="0" hangingPunct="1">
+              <a:defRPr sz="1800" kern="1200">
+                <a:solidFill>
+                  <a:schemeClr val="lt1"/>
+                </a:solidFill>
+                <a:latin typeface="+mn-lt"/>
+                <a:ea typeface="+mn-ea"/>
+                <a:cs typeface="+mn-cs"/>
+              </a:defRPr>
+            </a:lvl9pPr>
+          </a:lstStyle>
+          <a:p>
+            <a:pPr algn="ctr"/>
+            <a:endParaRPr/>
+          </a:p>
+        </p:txBody>
+      </p:sp>
+      <p:pic>
+        <p:nvPicPr>
+          <p:cNvPr id="11" name="Picture 10">
+            <a:extLst>
+              <a:ext uri="{FF2B5EF4-FFF2-40B4-BE49-F238E27FC236}">
+                <a16:creationId xmlns:a16="http://schemas.microsoft.com/office/drawing/2014/main" id="{A5E3C0F1-B6E0-8258-110F-35FD930F28FA}"/>
+              </a:ext>
+            </a:extLst>
+          </p:cNvPr>
+          <p:cNvPicPr>
+            <a:picLocks noChangeAspect="1"/>
+          </p:cNvPicPr>
+          <p:nvPr/>
+        </p:nvPicPr>
+        <p:blipFill>
+          <a:blip r:embed="rId4"/>
+          <a:stretch>
+            <a:fillRect/>
+          </a:stretch>
+        </p:blipFill>
+        <p:spPr>
+          <a:xfrm>
+            <a:off x="3278981" y="4617690"/>
+            <a:ext cx="152400" cy="152400"/>
+          </a:xfrm>
+          <a:prstGeom prst="rect">
+            <a:avLst/>
+          </a:prstGeom>
+        </p:spPr>
+      </p:pic>
+      <p:pic>
+        <p:nvPicPr>
+          <p:cNvPr id="12" name="Picture 11">
+            <a:extLst>
+              <a:ext uri="{FF2B5EF4-FFF2-40B4-BE49-F238E27FC236}">
+                <a16:creationId xmlns:a16="http://schemas.microsoft.com/office/drawing/2014/main" id="{E79A410D-DC5C-312B-5315-005ACF180BBB}"/>
+              </a:ext>
+            </a:extLst>
+          </p:cNvPr>
+          <p:cNvPicPr>
+            <a:picLocks noChangeAspect="1"/>
+          </p:cNvPicPr>
+          <p:nvPr/>
+        </p:nvPicPr>
+        <p:blipFill>
+          <a:blip r:embed="rId4"/>
+          <a:stretch>
+            <a:fillRect/>
+          </a:stretch>
+        </p:blipFill>
+        <p:spPr>
+          <a:xfrm>
+            <a:off x="4855368" y="4617690"/>
+            <a:ext cx="152400" cy="152400"/>
+          </a:xfrm>
+          <a:prstGeom prst="rect">
+            <a:avLst/>
+          </a:prstGeom>
+        </p:spPr>
+      </p:pic>
+      <p:pic>
+        <p:nvPicPr>
+          <p:cNvPr id="13" name="Picture 12">
+            <a:extLst>
+              <a:ext uri="{FF2B5EF4-FFF2-40B4-BE49-F238E27FC236}">
+                <a16:creationId xmlns:a16="http://schemas.microsoft.com/office/drawing/2014/main" id="{3D43A16A-B3F6-5634-A50F-C84A421FD69A}"/>
+              </a:ext>
+            </a:extLst>
+          </p:cNvPr>
+          <p:cNvPicPr>
+            <a:picLocks noChangeAspect="1"/>
+          </p:cNvPicPr>
+          <p:nvPr/>
+        </p:nvPicPr>
+        <p:blipFill>
+          <a:blip r:embed="rId4"/>
+          <a:stretch>
+            <a:fillRect/>
+          </a:stretch>
+        </p:blipFill>
+        <p:spPr>
+          <a:xfrm>
+            <a:off x="6507956" y="4617690"/>
+            <a:ext cx="152400" cy="152400"/>
+          </a:xfrm>
+          <a:prstGeom prst="rect">
+            <a:avLst/>
+          </a:prstGeom>
+        </p:spPr>
+      </p:pic>
+      <p:pic>
+        <p:nvPicPr>
+          <p:cNvPr id="14" name="Picture 13">
+            <a:extLst>
+              <a:ext uri="{FF2B5EF4-FFF2-40B4-BE49-F238E27FC236}">
+                <a16:creationId xmlns:a16="http://schemas.microsoft.com/office/drawing/2014/main" id="{E42FED19-1D18-ED57-ABF1-6E093434C1E2}"/>
+              </a:ext>
+            </a:extLst>
+          </p:cNvPr>
+          <p:cNvPicPr>
+            <a:picLocks noChangeAspect="1"/>
+          </p:cNvPicPr>
+          <p:nvPr/>
+        </p:nvPicPr>
+        <p:blipFill>
+          <a:blip r:embed="rId4"/>
+          <a:stretch>
+            <a:fillRect/>
+          </a:stretch>
+        </p:blipFill>
+        <p:spPr>
+          <a:xfrm>
+            <a:off x="8274843" y="4617690"/>
+            <a:ext cx="152400" cy="152400"/>
+          </a:xfrm>
+          <a:prstGeom prst="rect">
+            <a:avLst/>
+          </a:prstGeom>
+        </p:spPr>
+      </p:pic>
+      <p:sp>
+        <p:nvSpPr>
+          <p:cNvPr id="15" name="TextBox 8">
+            <a:extLst>
+              <a:ext uri="{FF2B5EF4-FFF2-40B4-BE49-F238E27FC236}">
+                <a16:creationId xmlns:a16="http://schemas.microsoft.com/office/drawing/2014/main" id="{454BEB1D-70EE-4861-E048-CE4DCCB2C692}"/>
+              </a:ext>
+            </a:extLst>
+          </p:cNvPr>
           <p:cNvSpPr txBox="1"/>
           <p:nvPr/>
         </p:nvSpPr>
         <p:spPr>
           <a:xfrm>
-            <a:off x="4592780" y="2455664"/>
-            <a:ext cx="3006290" cy="190500"/>
+            <a:off x="470296" y="2392709"/>
+            <a:ext cx="11251406" cy="1005780"/>
           </a:xfrm>
           <a:prstGeom prst="rect">
             <a:avLst/>
@@ -3201,54 +3606,113 @@
           <a:bodyPr wrap="square" lIns="0" tIns="0" rIns="0" bIns="0" anchor="t">
             <a:spAutoFit/>
           </a:bodyPr>
-          <a:lstStyle/>
-          <a:p>
-            <a:pPr algn="ctr"/>
-            <a:r>
-              <a:rPr sz="975" b="1" i="0" u="none">
-                <a:solidFill>
-                  <a:srgbClr val="3B82F6"/>
-                </a:solidFill>
-                <a:latin typeface="system-ui"/>
-              </a:rPr>
-              <a:t>HEROVIRED CAPSTONE PROJECT</a:t>
-            </a:r>
-          </a:p>
-        </p:txBody>
-      </p:sp>
-      <p:sp>
-        <p:nvSpPr>
-          <p:cNvPr id="5" name="TextBox 4"/>
-          <p:cNvSpPr txBox="1"/>
-          <p:nvPr/>
-        </p:nvSpPr>
-        <p:spPr>
-          <a:xfrm>
-            <a:off x="190500" y="2970014"/>
-            <a:ext cx="11811000" cy="1051321"/>
-          </a:xfrm>
-          <a:prstGeom prst="rect">
-            <a:avLst/>
-          </a:prstGeom>
-          <a:noFill/>
-        </p:spPr>
-        <p:txBody>
-          <a:bodyPr wrap="square" lIns="0" tIns="0" rIns="0" bIns="0" anchor="t">
-            <a:spAutoFit/>
-          </a:bodyPr>
-          <a:lstStyle/>
+          <a:lstStyle>
+            <a:defPPr>
+              <a:defRPr lang="en-US"/>
+            </a:defPPr>
+            <a:lvl1pPr marL="0" algn="l" defTabSz="457200" rtl="0" eaLnBrk="1" latinLnBrk="0" hangingPunct="1">
+              <a:defRPr sz="1800" kern="1200">
+                <a:solidFill>
+                  <a:schemeClr val="tx1"/>
+                </a:solidFill>
+                <a:latin typeface="+mn-lt"/>
+                <a:ea typeface="+mn-ea"/>
+                <a:cs typeface="+mn-cs"/>
+              </a:defRPr>
+            </a:lvl1pPr>
+            <a:lvl2pPr marL="457200" algn="l" defTabSz="457200" rtl="0" eaLnBrk="1" latinLnBrk="0" hangingPunct="1">
+              <a:defRPr sz="1800" kern="1200">
+                <a:solidFill>
+                  <a:schemeClr val="tx1"/>
+                </a:solidFill>
+                <a:latin typeface="+mn-lt"/>
+                <a:ea typeface="+mn-ea"/>
+                <a:cs typeface="+mn-cs"/>
+              </a:defRPr>
+            </a:lvl2pPr>
+            <a:lvl3pPr marL="914400" algn="l" defTabSz="457200" rtl="0" eaLnBrk="1" latinLnBrk="0" hangingPunct="1">
+              <a:defRPr sz="1800" kern="1200">
+                <a:solidFill>
+                  <a:schemeClr val="tx1"/>
+                </a:solidFill>
+                <a:latin typeface="+mn-lt"/>
+                <a:ea typeface="+mn-ea"/>
+                <a:cs typeface="+mn-cs"/>
+              </a:defRPr>
+            </a:lvl3pPr>
+            <a:lvl4pPr marL="1371600" algn="l" defTabSz="457200" rtl="0" eaLnBrk="1" latinLnBrk="0" hangingPunct="1">
+              <a:defRPr sz="1800" kern="1200">
+                <a:solidFill>
+                  <a:schemeClr val="tx1"/>
+                </a:solidFill>
+                <a:latin typeface="+mn-lt"/>
+                <a:ea typeface="+mn-ea"/>
+                <a:cs typeface="+mn-cs"/>
+              </a:defRPr>
+            </a:lvl4pPr>
+            <a:lvl5pPr marL="1828800" algn="l" defTabSz="457200" rtl="0" eaLnBrk="1" latinLnBrk="0" hangingPunct="1">
+              <a:defRPr sz="1800" kern="1200">
+                <a:solidFill>
+                  <a:schemeClr val="tx1"/>
+                </a:solidFill>
+                <a:latin typeface="+mn-lt"/>
+                <a:ea typeface="+mn-ea"/>
+                <a:cs typeface="+mn-cs"/>
+              </a:defRPr>
+            </a:lvl5pPr>
+            <a:lvl6pPr marL="2286000" algn="l" defTabSz="457200" rtl="0" eaLnBrk="1" latinLnBrk="0" hangingPunct="1">
+              <a:defRPr sz="1800" kern="1200">
+                <a:solidFill>
+                  <a:schemeClr val="tx1"/>
+                </a:solidFill>
+                <a:latin typeface="+mn-lt"/>
+                <a:ea typeface="+mn-ea"/>
+                <a:cs typeface="+mn-cs"/>
+              </a:defRPr>
+            </a:lvl6pPr>
+            <a:lvl7pPr marL="2743200" algn="l" defTabSz="457200" rtl="0" eaLnBrk="1" latinLnBrk="0" hangingPunct="1">
+              <a:defRPr sz="1800" kern="1200">
+                <a:solidFill>
+                  <a:schemeClr val="tx1"/>
+                </a:solidFill>
+                <a:latin typeface="+mn-lt"/>
+                <a:ea typeface="+mn-ea"/>
+                <a:cs typeface="+mn-cs"/>
+              </a:defRPr>
+            </a:lvl7pPr>
+            <a:lvl8pPr marL="3200400" algn="l" defTabSz="457200" rtl="0" eaLnBrk="1" latinLnBrk="0" hangingPunct="1">
+              <a:defRPr sz="1800" kern="1200">
+                <a:solidFill>
+                  <a:schemeClr val="tx1"/>
+                </a:solidFill>
+                <a:latin typeface="+mn-lt"/>
+                <a:ea typeface="+mn-ea"/>
+                <a:cs typeface="+mn-cs"/>
+              </a:defRPr>
+            </a:lvl8pPr>
+            <a:lvl9pPr marL="3657600" algn="l" defTabSz="457200" rtl="0" eaLnBrk="1" latinLnBrk="0" hangingPunct="1">
+              <a:defRPr sz="1800" kern="1200">
+                <a:solidFill>
+                  <a:schemeClr val="tx1"/>
+                </a:solidFill>
+                <a:latin typeface="+mn-lt"/>
+                <a:ea typeface="+mn-ea"/>
+                <a:cs typeface="+mn-cs"/>
+              </a:defRPr>
+            </a:lvl9pPr>
+          </a:lstStyle>
           <a:p>
             <a:pPr algn="ctr">
               <a:lnSpc>
-                <a:spcPts val="4140"/>
+                <a:spcPts val="3959"/>
               </a:lnSpc>
             </a:pPr>
             <a:r>
-              <a:rPr sz="3450" b="1" i="0" u="none">
-                <a:solidFill>
-                  <a:srgbClr val="F8FAFC"/>
-                </a:solidFill>
-                <a:latin typeface="system-ui"/>
+              <a:rPr sz="3300" b="1" i="0" u="none">
+                <a:solidFill>
+                  <a:srgbClr val="FFFFFF"/>
+                </a:solidFill>
+                <a:latin typeface="Inter"/>
               </a:rPr>
               <a:t>End-to-End DevOps Pipeline for a Web Application with CI/CD</a:t>
             </a:r>
@@ -3257,14 +3721,20 @@
       </p:sp>
       <p:sp>
         <p:nvSpPr>
-          <p:cNvPr id="6" name="TextBox 5"/>
+          <p:cNvPr id="16" name="TextBox 9">
+            <a:extLst>
+              <a:ext uri="{FF2B5EF4-FFF2-40B4-BE49-F238E27FC236}">
+                <a16:creationId xmlns:a16="http://schemas.microsoft.com/office/drawing/2014/main" id="{34C33777-76DB-D1AA-C061-889632B07CB7}"/>
+              </a:ext>
+            </a:extLst>
+          </p:cNvPr>
           <p:cNvSpPr txBox="1"/>
           <p:nvPr/>
         </p:nvSpPr>
         <p:spPr>
           <a:xfrm>
-            <a:off x="381000" y="4173735"/>
-            <a:ext cx="11430000" cy="285750"/>
+            <a:off x="1476375" y="3550890"/>
+            <a:ext cx="9239250" cy="200025"/>
           </a:xfrm>
           <a:prstGeom prst="rect">
             <a:avLst/>
@@ -3275,21 +3745,921 @@
           <a:bodyPr wrap="none" lIns="0" tIns="0" rIns="0" bIns="0" anchor="t">
             <a:spAutoFit/>
           </a:bodyPr>
-          <a:lstStyle/>
-          <a:p>
-            <a:pPr algn="ctr">
-              <a:lnSpc>
-                <a:spcPts val="2250"/>
-              </a:lnSpc>
-            </a:pPr>
-            <a:r>
-              <a:rPr sz="1500" b="0" i="0" u="none">
+          <a:lstStyle>
+            <a:defPPr>
+              <a:defRPr lang="en-US"/>
+            </a:defPPr>
+            <a:lvl1pPr marL="0" algn="l" defTabSz="457200" rtl="0" eaLnBrk="1" latinLnBrk="0" hangingPunct="1">
+              <a:defRPr sz="1800" kern="1200">
+                <a:solidFill>
+                  <a:schemeClr val="tx1"/>
+                </a:solidFill>
+                <a:latin typeface="+mn-lt"/>
+                <a:ea typeface="+mn-ea"/>
+                <a:cs typeface="+mn-cs"/>
+              </a:defRPr>
+            </a:lvl1pPr>
+            <a:lvl2pPr marL="457200" algn="l" defTabSz="457200" rtl="0" eaLnBrk="1" latinLnBrk="0" hangingPunct="1">
+              <a:defRPr sz="1800" kern="1200">
+                <a:solidFill>
+                  <a:schemeClr val="tx1"/>
+                </a:solidFill>
+                <a:latin typeface="+mn-lt"/>
+                <a:ea typeface="+mn-ea"/>
+                <a:cs typeface="+mn-cs"/>
+              </a:defRPr>
+            </a:lvl2pPr>
+            <a:lvl3pPr marL="914400" algn="l" defTabSz="457200" rtl="0" eaLnBrk="1" latinLnBrk="0" hangingPunct="1">
+              <a:defRPr sz="1800" kern="1200">
+                <a:solidFill>
+                  <a:schemeClr val="tx1"/>
+                </a:solidFill>
+                <a:latin typeface="+mn-lt"/>
+                <a:ea typeface="+mn-ea"/>
+                <a:cs typeface="+mn-cs"/>
+              </a:defRPr>
+            </a:lvl3pPr>
+            <a:lvl4pPr marL="1371600" algn="l" defTabSz="457200" rtl="0" eaLnBrk="1" latinLnBrk="0" hangingPunct="1">
+              <a:defRPr sz="1800" kern="1200">
+                <a:solidFill>
+                  <a:schemeClr val="tx1"/>
+                </a:solidFill>
+                <a:latin typeface="+mn-lt"/>
+                <a:ea typeface="+mn-ea"/>
+                <a:cs typeface="+mn-cs"/>
+              </a:defRPr>
+            </a:lvl4pPr>
+            <a:lvl5pPr marL="1828800" algn="l" defTabSz="457200" rtl="0" eaLnBrk="1" latinLnBrk="0" hangingPunct="1">
+              <a:defRPr sz="1800" kern="1200">
+                <a:solidFill>
+                  <a:schemeClr val="tx1"/>
+                </a:solidFill>
+                <a:latin typeface="+mn-lt"/>
+                <a:ea typeface="+mn-ea"/>
+                <a:cs typeface="+mn-cs"/>
+              </a:defRPr>
+            </a:lvl5pPr>
+            <a:lvl6pPr marL="2286000" algn="l" defTabSz="457200" rtl="0" eaLnBrk="1" latinLnBrk="0" hangingPunct="1">
+              <a:defRPr sz="1800" kern="1200">
+                <a:solidFill>
+                  <a:schemeClr val="tx1"/>
+                </a:solidFill>
+                <a:latin typeface="+mn-lt"/>
+                <a:ea typeface="+mn-ea"/>
+                <a:cs typeface="+mn-cs"/>
+              </a:defRPr>
+            </a:lvl6pPr>
+            <a:lvl7pPr marL="2743200" algn="l" defTabSz="457200" rtl="0" eaLnBrk="1" latinLnBrk="0" hangingPunct="1">
+              <a:defRPr sz="1800" kern="1200">
+                <a:solidFill>
+                  <a:schemeClr val="tx1"/>
+                </a:solidFill>
+                <a:latin typeface="+mn-lt"/>
+                <a:ea typeface="+mn-ea"/>
+                <a:cs typeface="+mn-cs"/>
+              </a:defRPr>
+            </a:lvl7pPr>
+            <a:lvl8pPr marL="3200400" algn="l" defTabSz="457200" rtl="0" eaLnBrk="1" latinLnBrk="0" hangingPunct="1">
+              <a:defRPr sz="1800" kern="1200">
+                <a:solidFill>
+                  <a:schemeClr val="tx1"/>
+                </a:solidFill>
+                <a:latin typeface="+mn-lt"/>
+                <a:ea typeface="+mn-ea"/>
+                <a:cs typeface="+mn-cs"/>
+              </a:defRPr>
+            </a:lvl8pPr>
+            <a:lvl9pPr marL="3657600" algn="l" defTabSz="457200" rtl="0" eaLnBrk="1" latinLnBrk="0" hangingPunct="1">
+              <a:defRPr sz="1800" kern="1200">
+                <a:solidFill>
+                  <a:schemeClr val="tx1"/>
+                </a:solidFill>
+                <a:latin typeface="+mn-lt"/>
+                <a:ea typeface="+mn-ea"/>
+                <a:cs typeface="+mn-cs"/>
+              </a:defRPr>
+            </a:lvl9pPr>
+          </a:lstStyle>
+          <a:p>
+            <a:pPr algn="ctr"/>
+            <a:r>
+              <a:rPr sz="1350" b="0" i="0" u="none">
                 <a:solidFill>
                   <a:srgbClr val="94A3B8"/>
                 </a:solidFill>
-                <a:latin typeface="system-ui"/>
+                <a:latin typeface="Inter"/>
               </a:rPr>
               <a:t>Complete Presentation: Objectives, AWS Architecture, Sprint Status &amp; Evidence Standards</a:t>
+            </a:r>
+          </a:p>
+        </p:txBody>
+      </p:sp>
+      <p:sp>
+        <p:nvSpPr>
+          <p:cNvPr id="17" name="TextBox 10">
+            <a:extLst>
+              <a:ext uri="{FF2B5EF4-FFF2-40B4-BE49-F238E27FC236}">
+                <a16:creationId xmlns:a16="http://schemas.microsoft.com/office/drawing/2014/main" id="{AF924A02-A4EB-A945-D19F-54ED1277EE59}"/>
+              </a:ext>
+            </a:extLst>
+          </p:cNvPr>
+          <p:cNvSpPr txBox="1"/>
+          <p:nvPr/>
+        </p:nvSpPr>
+        <p:spPr>
+          <a:xfrm>
+            <a:off x="4071937" y="1935509"/>
+            <a:ext cx="4048125" cy="161925"/>
+          </a:xfrm>
+          <a:prstGeom prst="rect">
+            <a:avLst/>
+          </a:prstGeom>
+          <a:noFill/>
+        </p:spPr>
+        <p:txBody>
+          <a:bodyPr wrap="none" lIns="0" tIns="0" rIns="0" bIns="0" anchor="t">
+            <a:spAutoFit/>
+          </a:bodyPr>
+          <a:lstStyle>
+            <a:defPPr>
+              <a:defRPr lang="en-US"/>
+            </a:defPPr>
+            <a:lvl1pPr marL="0" algn="l" defTabSz="457200" rtl="0" eaLnBrk="1" latinLnBrk="0" hangingPunct="1">
+              <a:defRPr sz="1800" kern="1200">
+                <a:solidFill>
+                  <a:schemeClr val="tx1"/>
+                </a:solidFill>
+                <a:latin typeface="+mn-lt"/>
+                <a:ea typeface="+mn-ea"/>
+                <a:cs typeface="+mn-cs"/>
+              </a:defRPr>
+            </a:lvl1pPr>
+            <a:lvl2pPr marL="457200" algn="l" defTabSz="457200" rtl="0" eaLnBrk="1" latinLnBrk="0" hangingPunct="1">
+              <a:defRPr sz="1800" kern="1200">
+                <a:solidFill>
+                  <a:schemeClr val="tx1"/>
+                </a:solidFill>
+                <a:latin typeface="+mn-lt"/>
+                <a:ea typeface="+mn-ea"/>
+                <a:cs typeface="+mn-cs"/>
+              </a:defRPr>
+            </a:lvl2pPr>
+            <a:lvl3pPr marL="914400" algn="l" defTabSz="457200" rtl="0" eaLnBrk="1" latinLnBrk="0" hangingPunct="1">
+              <a:defRPr sz="1800" kern="1200">
+                <a:solidFill>
+                  <a:schemeClr val="tx1"/>
+                </a:solidFill>
+                <a:latin typeface="+mn-lt"/>
+                <a:ea typeface="+mn-ea"/>
+                <a:cs typeface="+mn-cs"/>
+              </a:defRPr>
+            </a:lvl3pPr>
+            <a:lvl4pPr marL="1371600" algn="l" defTabSz="457200" rtl="0" eaLnBrk="1" latinLnBrk="0" hangingPunct="1">
+              <a:defRPr sz="1800" kern="1200">
+                <a:solidFill>
+                  <a:schemeClr val="tx1"/>
+                </a:solidFill>
+                <a:latin typeface="+mn-lt"/>
+                <a:ea typeface="+mn-ea"/>
+                <a:cs typeface="+mn-cs"/>
+              </a:defRPr>
+            </a:lvl4pPr>
+            <a:lvl5pPr marL="1828800" algn="l" defTabSz="457200" rtl="0" eaLnBrk="1" latinLnBrk="0" hangingPunct="1">
+              <a:defRPr sz="1800" kern="1200">
+                <a:solidFill>
+                  <a:schemeClr val="tx1"/>
+                </a:solidFill>
+                <a:latin typeface="+mn-lt"/>
+                <a:ea typeface="+mn-ea"/>
+                <a:cs typeface="+mn-cs"/>
+              </a:defRPr>
+            </a:lvl5pPr>
+            <a:lvl6pPr marL="2286000" algn="l" defTabSz="457200" rtl="0" eaLnBrk="1" latinLnBrk="0" hangingPunct="1">
+              <a:defRPr sz="1800" kern="1200">
+                <a:solidFill>
+                  <a:schemeClr val="tx1"/>
+                </a:solidFill>
+                <a:latin typeface="+mn-lt"/>
+                <a:ea typeface="+mn-ea"/>
+                <a:cs typeface="+mn-cs"/>
+              </a:defRPr>
+            </a:lvl6pPr>
+            <a:lvl7pPr marL="2743200" algn="l" defTabSz="457200" rtl="0" eaLnBrk="1" latinLnBrk="0" hangingPunct="1">
+              <a:defRPr sz="1800" kern="1200">
+                <a:solidFill>
+                  <a:schemeClr val="tx1"/>
+                </a:solidFill>
+                <a:latin typeface="+mn-lt"/>
+                <a:ea typeface="+mn-ea"/>
+                <a:cs typeface="+mn-cs"/>
+              </a:defRPr>
+            </a:lvl7pPr>
+            <a:lvl8pPr marL="3200400" algn="l" defTabSz="457200" rtl="0" eaLnBrk="1" latinLnBrk="0" hangingPunct="1">
+              <a:defRPr sz="1800" kern="1200">
+                <a:solidFill>
+                  <a:schemeClr val="tx1"/>
+                </a:solidFill>
+                <a:latin typeface="+mn-lt"/>
+                <a:ea typeface="+mn-ea"/>
+                <a:cs typeface="+mn-cs"/>
+              </a:defRPr>
+            </a:lvl8pPr>
+            <a:lvl9pPr marL="3657600" algn="l" defTabSz="457200" rtl="0" eaLnBrk="1" latinLnBrk="0" hangingPunct="1">
+              <a:defRPr sz="1800" kern="1200">
+                <a:solidFill>
+                  <a:schemeClr val="tx1"/>
+                </a:solidFill>
+                <a:latin typeface="+mn-lt"/>
+                <a:ea typeface="+mn-ea"/>
+                <a:cs typeface="+mn-cs"/>
+              </a:defRPr>
+            </a:lvl9pPr>
+          </a:lstStyle>
+          <a:p>
+            <a:pPr algn="ctr"/>
+            <a:r>
+              <a:rPr sz="1050" b="1" i="0" u="none">
+                <a:solidFill>
+                  <a:srgbClr val="A78BFA"/>
+                </a:solidFill>
+                <a:latin typeface="Inter"/>
+              </a:rPr>
+              <a:t>HEROVIRED CAPSTONE PROJECT • GROUP 4</a:t>
+            </a:r>
+          </a:p>
+        </p:txBody>
+      </p:sp>
+      <p:sp>
+        <p:nvSpPr>
+          <p:cNvPr id="18" name="TextBox 11">
+            <a:extLst>
+              <a:ext uri="{FF2B5EF4-FFF2-40B4-BE49-F238E27FC236}">
+                <a16:creationId xmlns:a16="http://schemas.microsoft.com/office/drawing/2014/main" id="{5F18E38F-05F8-427E-567C-9A6BC4DE0274}"/>
+              </a:ext>
+            </a:extLst>
+          </p:cNvPr>
+          <p:cNvSpPr txBox="1"/>
+          <p:nvPr/>
+        </p:nvSpPr>
+        <p:spPr>
+          <a:xfrm>
+            <a:off x="2024062" y="4331940"/>
+            <a:ext cx="8143875" cy="152400"/>
+          </a:xfrm>
+          <a:prstGeom prst="rect">
+            <a:avLst/>
+          </a:prstGeom>
+          <a:noFill/>
+        </p:spPr>
+        <p:txBody>
+          <a:bodyPr wrap="none" lIns="0" tIns="0" rIns="0" bIns="0" anchor="t">
+            <a:spAutoFit/>
+          </a:bodyPr>
+          <a:lstStyle>
+            <a:defPPr>
+              <a:defRPr lang="en-US"/>
+            </a:defPPr>
+            <a:lvl1pPr marL="0" algn="l" defTabSz="457200" rtl="0" eaLnBrk="1" latinLnBrk="0" hangingPunct="1">
+              <a:defRPr sz="1800" kern="1200">
+                <a:solidFill>
+                  <a:schemeClr val="tx1"/>
+                </a:solidFill>
+                <a:latin typeface="+mn-lt"/>
+                <a:ea typeface="+mn-ea"/>
+                <a:cs typeface="+mn-cs"/>
+              </a:defRPr>
+            </a:lvl1pPr>
+            <a:lvl2pPr marL="457200" algn="l" defTabSz="457200" rtl="0" eaLnBrk="1" latinLnBrk="0" hangingPunct="1">
+              <a:defRPr sz="1800" kern="1200">
+                <a:solidFill>
+                  <a:schemeClr val="tx1"/>
+                </a:solidFill>
+                <a:latin typeface="+mn-lt"/>
+                <a:ea typeface="+mn-ea"/>
+                <a:cs typeface="+mn-cs"/>
+              </a:defRPr>
+            </a:lvl2pPr>
+            <a:lvl3pPr marL="914400" algn="l" defTabSz="457200" rtl="0" eaLnBrk="1" latinLnBrk="0" hangingPunct="1">
+              <a:defRPr sz="1800" kern="1200">
+                <a:solidFill>
+                  <a:schemeClr val="tx1"/>
+                </a:solidFill>
+                <a:latin typeface="+mn-lt"/>
+                <a:ea typeface="+mn-ea"/>
+                <a:cs typeface="+mn-cs"/>
+              </a:defRPr>
+            </a:lvl3pPr>
+            <a:lvl4pPr marL="1371600" algn="l" defTabSz="457200" rtl="0" eaLnBrk="1" latinLnBrk="0" hangingPunct="1">
+              <a:defRPr sz="1800" kern="1200">
+                <a:solidFill>
+                  <a:schemeClr val="tx1"/>
+                </a:solidFill>
+                <a:latin typeface="+mn-lt"/>
+                <a:ea typeface="+mn-ea"/>
+                <a:cs typeface="+mn-cs"/>
+              </a:defRPr>
+            </a:lvl4pPr>
+            <a:lvl5pPr marL="1828800" algn="l" defTabSz="457200" rtl="0" eaLnBrk="1" latinLnBrk="0" hangingPunct="1">
+              <a:defRPr sz="1800" kern="1200">
+                <a:solidFill>
+                  <a:schemeClr val="tx1"/>
+                </a:solidFill>
+                <a:latin typeface="+mn-lt"/>
+                <a:ea typeface="+mn-ea"/>
+                <a:cs typeface="+mn-cs"/>
+              </a:defRPr>
+            </a:lvl5pPr>
+            <a:lvl6pPr marL="2286000" algn="l" defTabSz="457200" rtl="0" eaLnBrk="1" latinLnBrk="0" hangingPunct="1">
+              <a:defRPr sz="1800" kern="1200">
+                <a:solidFill>
+                  <a:schemeClr val="tx1"/>
+                </a:solidFill>
+                <a:latin typeface="+mn-lt"/>
+                <a:ea typeface="+mn-ea"/>
+                <a:cs typeface="+mn-cs"/>
+              </a:defRPr>
+            </a:lvl6pPr>
+            <a:lvl7pPr marL="2743200" algn="l" defTabSz="457200" rtl="0" eaLnBrk="1" latinLnBrk="0" hangingPunct="1">
+              <a:defRPr sz="1800" kern="1200">
+                <a:solidFill>
+                  <a:schemeClr val="tx1"/>
+                </a:solidFill>
+                <a:latin typeface="+mn-lt"/>
+                <a:ea typeface="+mn-ea"/>
+                <a:cs typeface="+mn-cs"/>
+              </a:defRPr>
+            </a:lvl7pPr>
+            <a:lvl8pPr marL="3200400" algn="l" defTabSz="457200" rtl="0" eaLnBrk="1" latinLnBrk="0" hangingPunct="1">
+              <a:defRPr sz="1800" kern="1200">
+                <a:solidFill>
+                  <a:schemeClr val="tx1"/>
+                </a:solidFill>
+                <a:latin typeface="+mn-lt"/>
+                <a:ea typeface="+mn-ea"/>
+                <a:cs typeface="+mn-cs"/>
+              </a:defRPr>
+            </a:lvl8pPr>
+            <a:lvl9pPr marL="3657600" algn="l" defTabSz="457200" rtl="0" eaLnBrk="1" latinLnBrk="0" hangingPunct="1">
+              <a:defRPr sz="1800" kern="1200">
+                <a:solidFill>
+                  <a:schemeClr val="tx1"/>
+                </a:solidFill>
+                <a:latin typeface="+mn-lt"/>
+                <a:ea typeface="+mn-ea"/>
+                <a:cs typeface="+mn-cs"/>
+              </a:defRPr>
+            </a:lvl9pPr>
+          </a:lstStyle>
+          <a:p>
+            <a:pPr algn="ctr"/>
+            <a:r>
+              <a:rPr sz="975" b="1" i="0" u="none">
+                <a:solidFill>
+                  <a:srgbClr val="38BDF8"/>
+                </a:solidFill>
+                <a:latin typeface="Inter"/>
+              </a:rPr>
+              <a:t>GROUP MEMBERS</a:t>
+            </a:r>
+          </a:p>
+        </p:txBody>
+      </p:sp>
+      <p:sp>
+        <p:nvSpPr>
+          <p:cNvPr id="19" name="TextBox 12">
+            <a:extLst>
+              <a:ext uri="{FF2B5EF4-FFF2-40B4-BE49-F238E27FC236}">
+                <a16:creationId xmlns:a16="http://schemas.microsoft.com/office/drawing/2014/main" id="{05623A9B-31FC-412A-149F-1752E6D94BD1}"/>
+              </a:ext>
+            </a:extLst>
+          </p:cNvPr>
+          <p:cNvSpPr txBox="1"/>
+          <p:nvPr/>
+        </p:nvSpPr>
+        <p:spPr>
+          <a:xfrm>
+            <a:off x="3136106" y="4598640"/>
+            <a:ext cx="981075" cy="190500"/>
+          </a:xfrm>
+          <a:prstGeom prst="rect">
+            <a:avLst/>
+          </a:prstGeom>
+          <a:noFill/>
+        </p:spPr>
+        <p:txBody>
+          <a:bodyPr wrap="none" lIns="228600" tIns="0" rIns="0" bIns="0" anchor="t">
+            <a:spAutoFit/>
+          </a:bodyPr>
+          <a:lstStyle>
+            <a:defPPr>
+              <a:defRPr lang="en-US"/>
+            </a:defPPr>
+            <a:lvl1pPr marL="0" algn="l" defTabSz="457200" rtl="0" eaLnBrk="1" latinLnBrk="0" hangingPunct="1">
+              <a:defRPr sz="1800" kern="1200">
+                <a:solidFill>
+                  <a:schemeClr val="tx1"/>
+                </a:solidFill>
+                <a:latin typeface="+mn-lt"/>
+                <a:ea typeface="+mn-ea"/>
+                <a:cs typeface="+mn-cs"/>
+              </a:defRPr>
+            </a:lvl1pPr>
+            <a:lvl2pPr marL="457200" algn="l" defTabSz="457200" rtl="0" eaLnBrk="1" latinLnBrk="0" hangingPunct="1">
+              <a:defRPr sz="1800" kern="1200">
+                <a:solidFill>
+                  <a:schemeClr val="tx1"/>
+                </a:solidFill>
+                <a:latin typeface="+mn-lt"/>
+                <a:ea typeface="+mn-ea"/>
+                <a:cs typeface="+mn-cs"/>
+              </a:defRPr>
+            </a:lvl2pPr>
+            <a:lvl3pPr marL="914400" algn="l" defTabSz="457200" rtl="0" eaLnBrk="1" latinLnBrk="0" hangingPunct="1">
+              <a:defRPr sz="1800" kern="1200">
+                <a:solidFill>
+                  <a:schemeClr val="tx1"/>
+                </a:solidFill>
+                <a:latin typeface="+mn-lt"/>
+                <a:ea typeface="+mn-ea"/>
+                <a:cs typeface="+mn-cs"/>
+              </a:defRPr>
+            </a:lvl3pPr>
+            <a:lvl4pPr marL="1371600" algn="l" defTabSz="457200" rtl="0" eaLnBrk="1" latinLnBrk="0" hangingPunct="1">
+              <a:defRPr sz="1800" kern="1200">
+                <a:solidFill>
+                  <a:schemeClr val="tx1"/>
+                </a:solidFill>
+                <a:latin typeface="+mn-lt"/>
+                <a:ea typeface="+mn-ea"/>
+                <a:cs typeface="+mn-cs"/>
+              </a:defRPr>
+            </a:lvl4pPr>
+            <a:lvl5pPr marL="1828800" algn="l" defTabSz="457200" rtl="0" eaLnBrk="1" latinLnBrk="0" hangingPunct="1">
+              <a:defRPr sz="1800" kern="1200">
+                <a:solidFill>
+                  <a:schemeClr val="tx1"/>
+                </a:solidFill>
+                <a:latin typeface="+mn-lt"/>
+                <a:ea typeface="+mn-ea"/>
+                <a:cs typeface="+mn-cs"/>
+              </a:defRPr>
+            </a:lvl5pPr>
+            <a:lvl6pPr marL="2286000" algn="l" defTabSz="457200" rtl="0" eaLnBrk="1" latinLnBrk="0" hangingPunct="1">
+              <a:defRPr sz="1800" kern="1200">
+                <a:solidFill>
+                  <a:schemeClr val="tx1"/>
+                </a:solidFill>
+                <a:latin typeface="+mn-lt"/>
+                <a:ea typeface="+mn-ea"/>
+                <a:cs typeface="+mn-cs"/>
+              </a:defRPr>
+            </a:lvl6pPr>
+            <a:lvl7pPr marL="2743200" algn="l" defTabSz="457200" rtl="0" eaLnBrk="1" latinLnBrk="0" hangingPunct="1">
+              <a:defRPr sz="1800" kern="1200">
+                <a:solidFill>
+                  <a:schemeClr val="tx1"/>
+                </a:solidFill>
+                <a:latin typeface="+mn-lt"/>
+                <a:ea typeface="+mn-ea"/>
+                <a:cs typeface="+mn-cs"/>
+              </a:defRPr>
+            </a:lvl7pPr>
+            <a:lvl8pPr marL="3200400" algn="l" defTabSz="457200" rtl="0" eaLnBrk="1" latinLnBrk="0" hangingPunct="1">
+              <a:defRPr sz="1800" kern="1200">
+                <a:solidFill>
+                  <a:schemeClr val="tx1"/>
+                </a:solidFill>
+                <a:latin typeface="+mn-lt"/>
+                <a:ea typeface="+mn-ea"/>
+                <a:cs typeface="+mn-cs"/>
+              </a:defRPr>
+            </a:lvl8pPr>
+            <a:lvl9pPr marL="3657600" algn="l" defTabSz="457200" rtl="0" eaLnBrk="1" latinLnBrk="0" hangingPunct="1">
+              <a:defRPr sz="1800" kern="1200">
+                <a:solidFill>
+                  <a:schemeClr val="tx1"/>
+                </a:solidFill>
+                <a:latin typeface="+mn-lt"/>
+                <a:ea typeface="+mn-ea"/>
+                <a:cs typeface="+mn-cs"/>
+              </a:defRPr>
+            </a:lvl9pPr>
+          </a:lstStyle>
+          <a:p>
+            <a:pPr algn="ctr"/>
+            <a:r>
+              <a:rPr sz="1200" b="1" i="0" u="none">
+                <a:solidFill>
+                  <a:srgbClr val="F1F5F9"/>
+                </a:solidFill>
+                <a:latin typeface="Inter"/>
+              </a:rPr>
+              <a:t>Harika</a:t>
+            </a:r>
+          </a:p>
+        </p:txBody>
+      </p:sp>
+      <p:sp>
+        <p:nvSpPr>
+          <p:cNvPr id="20" name="TextBox 13">
+            <a:extLst>
+              <a:ext uri="{FF2B5EF4-FFF2-40B4-BE49-F238E27FC236}">
+                <a16:creationId xmlns:a16="http://schemas.microsoft.com/office/drawing/2014/main" id="{7D1D14FB-5B28-C1AE-0781-FDFBC656A18A}"/>
+              </a:ext>
+            </a:extLst>
+          </p:cNvPr>
+          <p:cNvSpPr txBox="1"/>
+          <p:nvPr/>
+        </p:nvSpPr>
+        <p:spPr>
+          <a:xfrm>
+            <a:off x="4712493" y="4598640"/>
+            <a:ext cx="1057275" cy="190500"/>
+          </a:xfrm>
+          <a:prstGeom prst="rect">
+            <a:avLst/>
+          </a:prstGeom>
+          <a:noFill/>
+        </p:spPr>
+        <p:txBody>
+          <a:bodyPr wrap="none" lIns="228600" tIns="0" rIns="0" bIns="0" anchor="t">
+            <a:spAutoFit/>
+          </a:bodyPr>
+          <a:lstStyle>
+            <a:defPPr>
+              <a:defRPr lang="en-US"/>
+            </a:defPPr>
+            <a:lvl1pPr marL="0" algn="l" defTabSz="457200" rtl="0" eaLnBrk="1" latinLnBrk="0" hangingPunct="1">
+              <a:defRPr sz="1800" kern="1200">
+                <a:solidFill>
+                  <a:schemeClr val="tx1"/>
+                </a:solidFill>
+                <a:latin typeface="+mn-lt"/>
+                <a:ea typeface="+mn-ea"/>
+                <a:cs typeface="+mn-cs"/>
+              </a:defRPr>
+            </a:lvl1pPr>
+            <a:lvl2pPr marL="457200" algn="l" defTabSz="457200" rtl="0" eaLnBrk="1" latinLnBrk="0" hangingPunct="1">
+              <a:defRPr sz="1800" kern="1200">
+                <a:solidFill>
+                  <a:schemeClr val="tx1"/>
+                </a:solidFill>
+                <a:latin typeface="+mn-lt"/>
+                <a:ea typeface="+mn-ea"/>
+                <a:cs typeface="+mn-cs"/>
+              </a:defRPr>
+            </a:lvl2pPr>
+            <a:lvl3pPr marL="914400" algn="l" defTabSz="457200" rtl="0" eaLnBrk="1" latinLnBrk="0" hangingPunct="1">
+              <a:defRPr sz="1800" kern="1200">
+                <a:solidFill>
+                  <a:schemeClr val="tx1"/>
+                </a:solidFill>
+                <a:latin typeface="+mn-lt"/>
+                <a:ea typeface="+mn-ea"/>
+                <a:cs typeface="+mn-cs"/>
+              </a:defRPr>
+            </a:lvl3pPr>
+            <a:lvl4pPr marL="1371600" algn="l" defTabSz="457200" rtl="0" eaLnBrk="1" latinLnBrk="0" hangingPunct="1">
+              <a:defRPr sz="1800" kern="1200">
+                <a:solidFill>
+                  <a:schemeClr val="tx1"/>
+                </a:solidFill>
+                <a:latin typeface="+mn-lt"/>
+                <a:ea typeface="+mn-ea"/>
+                <a:cs typeface="+mn-cs"/>
+              </a:defRPr>
+            </a:lvl4pPr>
+            <a:lvl5pPr marL="1828800" algn="l" defTabSz="457200" rtl="0" eaLnBrk="1" latinLnBrk="0" hangingPunct="1">
+              <a:defRPr sz="1800" kern="1200">
+                <a:solidFill>
+                  <a:schemeClr val="tx1"/>
+                </a:solidFill>
+                <a:latin typeface="+mn-lt"/>
+                <a:ea typeface="+mn-ea"/>
+                <a:cs typeface="+mn-cs"/>
+              </a:defRPr>
+            </a:lvl5pPr>
+            <a:lvl6pPr marL="2286000" algn="l" defTabSz="457200" rtl="0" eaLnBrk="1" latinLnBrk="0" hangingPunct="1">
+              <a:defRPr sz="1800" kern="1200">
+                <a:solidFill>
+                  <a:schemeClr val="tx1"/>
+                </a:solidFill>
+                <a:latin typeface="+mn-lt"/>
+                <a:ea typeface="+mn-ea"/>
+                <a:cs typeface="+mn-cs"/>
+              </a:defRPr>
+            </a:lvl6pPr>
+            <a:lvl7pPr marL="2743200" algn="l" defTabSz="457200" rtl="0" eaLnBrk="1" latinLnBrk="0" hangingPunct="1">
+              <a:defRPr sz="1800" kern="1200">
+                <a:solidFill>
+                  <a:schemeClr val="tx1"/>
+                </a:solidFill>
+                <a:latin typeface="+mn-lt"/>
+                <a:ea typeface="+mn-ea"/>
+                <a:cs typeface="+mn-cs"/>
+              </a:defRPr>
+            </a:lvl7pPr>
+            <a:lvl8pPr marL="3200400" algn="l" defTabSz="457200" rtl="0" eaLnBrk="1" latinLnBrk="0" hangingPunct="1">
+              <a:defRPr sz="1800" kern="1200">
+                <a:solidFill>
+                  <a:schemeClr val="tx1"/>
+                </a:solidFill>
+                <a:latin typeface="+mn-lt"/>
+                <a:ea typeface="+mn-ea"/>
+                <a:cs typeface="+mn-cs"/>
+              </a:defRPr>
+            </a:lvl8pPr>
+            <a:lvl9pPr marL="3657600" algn="l" defTabSz="457200" rtl="0" eaLnBrk="1" latinLnBrk="0" hangingPunct="1">
+              <a:defRPr sz="1800" kern="1200">
+                <a:solidFill>
+                  <a:schemeClr val="tx1"/>
+                </a:solidFill>
+                <a:latin typeface="+mn-lt"/>
+                <a:ea typeface="+mn-ea"/>
+                <a:cs typeface="+mn-cs"/>
+              </a:defRPr>
+            </a:lvl9pPr>
+          </a:lstStyle>
+          <a:p>
+            <a:pPr algn="ctr"/>
+            <a:r>
+              <a:rPr sz="1200" b="1" i="0" u="none">
+                <a:solidFill>
+                  <a:srgbClr val="F1F5F9"/>
+                </a:solidFill>
+                <a:latin typeface="Inter"/>
+              </a:rPr>
+              <a:t>Ranjeet</a:t>
+            </a:r>
+          </a:p>
+        </p:txBody>
+      </p:sp>
+      <p:sp>
+        <p:nvSpPr>
+          <p:cNvPr id="21" name="TextBox 14">
+            <a:extLst>
+              <a:ext uri="{FF2B5EF4-FFF2-40B4-BE49-F238E27FC236}">
+                <a16:creationId xmlns:a16="http://schemas.microsoft.com/office/drawing/2014/main" id="{AE1ED12E-ADAD-ECE0-C410-73D8CA650F15}"/>
+              </a:ext>
+            </a:extLst>
+          </p:cNvPr>
+          <p:cNvSpPr txBox="1"/>
+          <p:nvPr/>
+        </p:nvSpPr>
+        <p:spPr>
+          <a:xfrm>
+            <a:off x="6365081" y="4598640"/>
+            <a:ext cx="1171575" cy="190500"/>
+          </a:xfrm>
+          <a:prstGeom prst="rect">
+            <a:avLst/>
+          </a:prstGeom>
+          <a:noFill/>
+        </p:spPr>
+        <p:txBody>
+          <a:bodyPr wrap="none" lIns="228600" tIns="0" rIns="0" bIns="0" anchor="t">
+            <a:spAutoFit/>
+          </a:bodyPr>
+          <a:lstStyle>
+            <a:defPPr>
+              <a:defRPr lang="en-US"/>
+            </a:defPPr>
+            <a:lvl1pPr marL="0" algn="l" defTabSz="457200" rtl="0" eaLnBrk="1" latinLnBrk="0" hangingPunct="1">
+              <a:defRPr sz="1800" kern="1200">
+                <a:solidFill>
+                  <a:schemeClr val="tx1"/>
+                </a:solidFill>
+                <a:latin typeface="+mn-lt"/>
+                <a:ea typeface="+mn-ea"/>
+                <a:cs typeface="+mn-cs"/>
+              </a:defRPr>
+            </a:lvl1pPr>
+            <a:lvl2pPr marL="457200" algn="l" defTabSz="457200" rtl="0" eaLnBrk="1" latinLnBrk="0" hangingPunct="1">
+              <a:defRPr sz="1800" kern="1200">
+                <a:solidFill>
+                  <a:schemeClr val="tx1"/>
+                </a:solidFill>
+                <a:latin typeface="+mn-lt"/>
+                <a:ea typeface="+mn-ea"/>
+                <a:cs typeface="+mn-cs"/>
+              </a:defRPr>
+            </a:lvl2pPr>
+            <a:lvl3pPr marL="914400" algn="l" defTabSz="457200" rtl="0" eaLnBrk="1" latinLnBrk="0" hangingPunct="1">
+              <a:defRPr sz="1800" kern="1200">
+                <a:solidFill>
+                  <a:schemeClr val="tx1"/>
+                </a:solidFill>
+                <a:latin typeface="+mn-lt"/>
+                <a:ea typeface="+mn-ea"/>
+                <a:cs typeface="+mn-cs"/>
+              </a:defRPr>
+            </a:lvl3pPr>
+            <a:lvl4pPr marL="1371600" algn="l" defTabSz="457200" rtl="0" eaLnBrk="1" latinLnBrk="0" hangingPunct="1">
+              <a:defRPr sz="1800" kern="1200">
+                <a:solidFill>
+                  <a:schemeClr val="tx1"/>
+                </a:solidFill>
+                <a:latin typeface="+mn-lt"/>
+                <a:ea typeface="+mn-ea"/>
+                <a:cs typeface="+mn-cs"/>
+              </a:defRPr>
+            </a:lvl4pPr>
+            <a:lvl5pPr marL="1828800" algn="l" defTabSz="457200" rtl="0" eaLnBrk="1" latinLnBrk="0" hangingPunct="1">
+              <a:defRPr sz="1800" kern="1200">
+                <a:solidFill>
+                  <a:schemeClr val="tx1"/>
+                </a:solidFill>
+                <a:latin typeface="+mn-lt"/>
+                <a:ea typeface="+mn-ea"/>
+                <a:cs typeface="+mn-cs"/>
+              </a:defRPr>
+            </a:lvl5pPr>
+            <a:lvl6pPr marL="2286000" algn="l" defTabSz="457200" rtl="0" eaLnBrk="1" latinLnBrk="0" hangingPunct="1">
+              <a:defRPr sz="1800" kern="1200">
+                <a:solidFill>
+                  <a:schemeClr val="tx1"/>
+                </a:solidFill>
+                <a:latin typeface="+mn-lt"/>
+                <a:ea typeface="+mn-ea"/>
+                <a:cs typeface="+mn-cs"/>
+              </a:defRPr>
+            </a:lvl6pPr>
+            <a:lvl7pPr marL="2743200" algn="l" defTabSz="457200" rtl="0" eaLnBrk="1" latinLnBrk="0" hangingPunct="1">
+              <a:defRPr sz="1800" kern="1200">
+                <a:solidFill>
+                  <a:schemeClr val="tx1"/>
+                </a:solidFill>
+                <a:latin typeface="+mn-lt"/>
+                <a:ea typeface="+mn-ea"/>
+                <a:cs typeface="+mn-cs"/>
+              </a:defRPr>
+            </a:lvl7pPr>
+            <a:lvl8pPr marL="3200400" algn="l" defTabSz="457200" rtl="0" eaLnBrk="1" latinLnBrk="0" hangingPunct="1">
+              <a:defRPr sz="1800" kern="1200">
+                <a:solidFill>
+                  <a:schemeClr val="tx1"/>
+                </a:solidFill>
+                <a:latin typeface="+mn-lt"/>
+                <a:ea typeface="+mn-ea"/>
+                <a:cs typeface="+mn-cs"/>
+              </a:defRPr>
+            </a:lvl8pPr>
+            <a:lvl9pPr marL="3657600" algn="l" defTabSz="457200" rtl="0" eaLnBrk="1" latinLnBrk="0" hangingPunct="1">
+              <a:defRPr sz="1800" kern="1200">
+                <a:solidFill>
+                  <a:schemeClr val="tx1"/>
+                </a:solidFill>
+                <a:latin typeface="+mn-lt"/>
+                <a:ea typeface="+mn-ea"/>
+                <a:cs typeface="+mn-cs"/>
+              </a:defRPr>
+            </a:lvl9pPr>
+          </a:lstStyle>
+          <a:p>
+            <a:pPr algn="ctr"/>
+            <a:r>
+              <a:rPr sz="1200" b="1" i="0" u="none">
+                <a:solidFill>
+                  <a:srgbClr val="F1F5F9"/>
+                </a:solidFill>
+                <a:latin typeface="Inter"/>
+              </a:rPr>
+              <a:t>Abhaash</a:t>
+            </a:r>
+          </a:p>
+        </p:txBody>
+      </p:sp>
+      <p:sp>
+        <p:nvSpPr>
+          <p:cNvPr id="22" name="TextBox 15">
+            <a:extLst>
+              <a:ext uri="{FF2B5EF4-FFF2-40B4-BE49-F238E27FC236}">
+                <a16:creationId xmlns:a16="http://schemas.microsoft.com/office/drawing/2014/main" id="{BEAFEFC9-8F91-3E9E-2DA2-FCCEF50D7BA7}"/>
+              </a:ext>
+            </a:extLst>
+          </p:cNvPr>
+          <p:cNvSpPr txBox="1"/>
+          <p:nvPr/>
+        </p:nvSpPr>
+        <p:spPr>
+          <a:xfrm>
+            <a:off x="8131968" y="4598640"/>
+            <a:ext cx="923925" cy="190500"/>
+          </a:xfrm>
+          <a:prstGeom prst="rect">
+            <a:avLst/>
+          </a:prstGeom>
+          <a:noFill/>
+        </p:spPr>
+        <p:txBody>
+          <a:bodyPr wrap="none" lIns="228600" tIns="0" rIns="0" bIns="0" anchor="t">
+            <a:spAutoFit/>
+          </a:bodyPr>
+          <a:lstStyle>
+            <a:defPPr>
+              <a:defRPr lang="en-US"/>
+            </a:defPPr>
+            <a:lvl1pPr marL="0" algn="l" defTabSz="457200" rtl="0" eaLnBrk="1" latinLnBrk="0" hangingPunct="1">
+              <a:defRPr sz="1800" kern="1200">
+                <a:solidFill>
+                  <a:schemeClr val="tx1"/>
+                </a:solidFill>
+                <a:latin typeface="+mn-lt"/>
+                <a:ea typeface="+mn-ea"/>
+                <a:cs typeface="+mn-cs"/>
+              </a:defRPr>
+            </a:lvl1pPr>
+            <a:lvl2pPr marL="457200" algn="l" defTabSz="457200" rtl="0" eaLnBrk="1" latinLnBrk="0" hangingPunct="1">
+              <a:defRPr sz="1800" kern="1200">
+                <a:solidFill>
+                  <a:schemeClr val="tx1"/>
+                </a:solidFill>
+                <a:latin typeface="+mn-lt"/>
+                <a:ea typeface="+mn-ea"/>
+                <a:cs typeface="+mn-cs"/>
+              </a:defRPr>
+            </a:lvl2pPr>
+            <a:lvl3pPr marL="914400" algn="l" defTabSz="457200" rtl="0" eaLnBrk="1" latinLnBrk="0" hangingPunct="1">
+              <a:defRPr sz="1800" kern="1200">
+                <a:solidFill>
+                  <a:schemeClr val="tx1"/>
+                </a:solidFill>
+                <a:latin typeface="+mn-lt"/>
+                <a:ea typeface="+mn-ea"/>
+                <a:cs typeface="+mn-cs"/>
+              </a:defRPr>
+            </a:lvl3pPr>
+            <a:lvl4pPr marL="1371600" algn="l" defTabSz="457200" rtl="0" eaLnBrk="1" latinLnBrk="0" hangingPunct="1">
+              <a:defRPr sz="1800" kern="1200">
+                <a:solidFill>
+                  <a:schemeClr val="tx1"/>
+                </a:solidFill>
+                <a:latin typeface="+mn-lt"/>
+                <a:ea typeface="+mn-ea"/>
+                <a:cs typeface="+mn-cs"/>
+              </a:defRPr>
+            </a:lvl4pPr>
+            <a:lvl5pPr marL="1828800" algn="l" defTabSz="457200" rtl="0" eaLnBrk="1" latinLnBrk="0" hangingPunct="1">
+              <a:defRPr sz="1800" kern="1200">
+                <a:solidFill>
+                  <a:schemeClr val="tx1"/>
+                </a:solidFill>
+                <a:latin typeface="+mn-lt"/>
+                <a:ea typeface="+mn-ea"/>
+                <a:cs typeface="+mn-cs"/>
+              </a:defRPr>
+            </a:lvl5pPr>
+            <a:lvl6pPr marL="2286000" algn="l" defTabSz="457200" rtl="0" eaLnBrk="1" latinLnBrk="0" hangingPunct="1">
+              <a:defRPr sz="1800" kern="1200">
+                <a:solidFill>
+                  <a:schemeClr val="tx1"/>
+                </a:solidFill>
+                <a:latin typeface="+mn-lt"/>
+                <a:ea typeface="+mn-ea"/>
+                <a:cs typeface="+mn-cs"/>
+              </a:defRPr>
+            </a:lvl6pPr>
+            <a:lvl7pPr marL="2743200" algn="l" defTabSz="457200" rtl="0" eaLnBrk="1" latinLnBrk="0" hangingPunct="1">
+              <a:defRPr sz="1800" kern="1200">
+                <a:solidFill>
+                  <a:schemeClr val="tx1"/>
+                </a:solidFill>
+                <a:latin typeface="+mn-lt"/>
+                <a:ea typeface="+mn-ea"/>
+                <a:cs typeface="+mn-cs"/>
+              </a:defRPr>
+            </a:lvl7pPr>
+            <a:lvl8pPr marL="3200400" algn="l" defTabSz="457200" rtl="0" eaLnBrk="1" latinLnBrk="0" hangingPunct="1">
+              <a:defRPr sz="1800" kern="1200">
+                <a:solidFill>
+                  <a:schemeClr val="tx1"/>
+                </a:solidFill>
+                <a:latin typeface="+mn-lt"/>
+                <a:ea typeface="+mn-ea"/>
+                <a:cs typeface="+mn-cs"/>
+              </a:defRPr>
+            </a:lvl8pPr>
+            <a:lvl9pPr marL="3657600" algn="l" defTabSz="457200" rtl="0" eaLnBrk="1" latinLnBrk="0" hangingPunct="1">
+              <a:defRPr sz="1800" kern="1200">
+                <a:solidFill>
+                  <a:schemeClr val="tx1"/>
+                </a:solidFill>
+                <a:latin typeface="+mn-lt"/>
+                <a:ea typeface="+mn-ea"/>
+                <a:cs typeface="+mn-cs"/>
+              </a:defRPr>
+            </a:lvl9pPr>
+          </a:lstStyle>
+          <a:p>
+            <a:pPr algn="ctr"/>
+            <a:r>
+              <a:rPr sz="1200" b="1" i="0" u="none">
+                <a:solidFill>
+                  <a:srgbClr val="F1F5F9"/>
+                </a:solidFill>
+                <a:latin typeface="Inter"/>
+              </a:rPr>
+              <a:t>Vivek</a:t>
             </a:r>
           </a:p>
         </p:txBody>

</xml_diff>

<commit_message>
HVC9 - Update in PPT
HVC9 - Update in PPT
</commit_message>
<xml_diff>
--- a/docs/evidence/HVB16A_Group4_CapstoneProject.pptx
+++ b/docs/evidence/HVB16A_Group4_CapstoneProject.pptx
@@ -4408,8 +4408,8 @@
         </p:nvSpPr>
         <p:spPr>
           <a:xfrm>
-            <a:off x="6365081" y="4598640"/>
-            <a:ext cx="1171575" cy="190500"/>
+            <a:off x="6595803" y="4598640"/>
+            <a:ext cx="710130" cy="184666"/>
           </a:xfrm>
           <a:prstGeom prst="rect">
             <a:avLst/>
@@ -4518,13 +4518,13 @@
           <a:p>
             <a:pPr algn="ctr"/>
             <a:r>
-              <a:rPr sz="1200" b="1" i="0" u="none">
+              <a:rPr sz="1200" b="1" i="0" u="none" dirty="0">
                 <a:solidFill>
                   <a:srgbClr val="F1F5F9"/>
                 </a:solidFill>
                 <a:latin typeface="Inter"/>
               </a:rPr>
-              <a:t>Abhaash</a:t>
+              <a:t>Abhash</a:t>
             </a:r>
           </a:p>
         </p:txBody>

</xml_diff>